<commit_message>
Enhance Attachment 1 feature description with sensor management, layout and sensitivity screens
Co-Authored-By: Claude Sonnet 5.5 <noreply@anthropic.com>
Claude-Session: https://claude.ai/code/session_01H4zPnzggxwhKnUJY9fpYxn
</commit_message>
<xml_diff>
--- a/MECS_PRO_Platform_Feature_Description_Attachment1.pptx
+++ b/MECS_PRO_Platform_Feature_Description_Attachment1.pptx
@@ -3337,6 +3337,11 @@
           <a:prstGeom prst="rect">
             <a:avLst/>
           </a:prstGeom>
+          <a:ln w="9525">
+            <a:solidFill>
+              <a:srgbClr val="D5DCE6"/>
+            </a:solidFill>
+          </a:ln>
         </p:spPr>
       </p:pic>
       <p:sp>
@@ -3503,7 +3508,7 @@
         </p:nvSpPr>
         <p:spPr>
           <a:xfrm>
-            <a:off x="7863840" y="1719072"/>
+            <a:off x="7863840" y="1709928"/>
             <a:ext cx="3840480" cy="274320"/>
           </a:xfrm>
           <a:prstGeom prst="rect">
@@ -3537,8 +3542,8 @@
         </p:nvSpPr>
         <p:spPr>
           <a:xfrm>
-            <a:off x="7863840" y="1993392"/>
-            <a:ext cx="3840480" cy="365760"/>
+            <a:off x="7863840" y="1965960"/>
+            <a:ext cx="3840480" cy="411480"/>
           </a:xfrm>
           <a:prstGeom prst="rect">
             <a:avLst/>
@@ -3552,13 +3557,13 @@
           <a:lstStyle/>
           <a:p>
             <a:r>
-              <a:rPr sz="1100" b="0">
+              <a:rPr sz="1050" b="0">
                 <a:solidFill>
                   <a:srgbClr val="1F2937"/>
                 </a:solidFill>
                 <a:latin typeface="Calibri"/>
               </a:rPr>
-              <a:t>Real-time view of wards, rooms, patients and sensors</a:t>
+              <a:t>Real-time view of wards, rooms, patients and sensors; layout editor for wards and rooms</a:t>
             </a:r>
           </a:p>
         </p:txBody>
@@ -3659,7 +3664,7 @@
         </p:nvSpPr>
         <p:spPr>
           <a:xfrm>
-            <a:off x="7863840" y="2523744"/>
+            <a:off x="7863840" y="2514600"/>
             <a:ext cx="3840480" cy="274320"/>
           </a:xfrm>
           <a:prstGeom prst="rect">
@@ -3693,8 +3698,8 @@
         </p:nvSpPr>
         <p:spPr>
           <a:xfrm>
-            <a:off x="7863840" y="2798064"/>
-            <a:ext cx="3840480" cy="365760"/>
+            <a:off x="7863840" y="2770632"/>
+            <a:ext cx="3840480" cy="411480"/>
           </a:xfrm>
           <a:prstGeom prst="rect">
             <a:avLst/>
@@ -3708,7 +3713,7 @@
           <a:lstStyle/>
           <a:p>
             <a:r>
-              <a:rPr sz="1100" b="0">
+              <a:rPr sz="1050" b="0">
                 <a:solidFill>
                   <a:srgbClr val="1F2937"/>
                 </a:solidFill>
@@ -3815,7 +3820,7 @@
         </p:nvSpPr>
         <p:spPr>
           <a:xfrm>
-            <a:off x="7863840" y="3328415"/>
+            <a:off x="7863840" y="3319272"/>
             <a:ext cx="3840480" cy="274320"/>
           </a:xfrm>
           <a:prstGeom prst="rect">
@@ -3849,8 +3854,8 @@
         </p:nvSpPr>
         <p:spPr>
           <a:xfrm>
-            <a:off x="7863840" y="3602736"/>
-            <a:ext cx="3840480" cy="365760"/>
+            <a:off x="7863840" y="3575303"/>
+            <a:ext cx="3840480" cy="411480"/>
           </a:xfrm>
           <a:prstGeom prst="rect">
             <a:avLst/>
@@ -3864,13 +3869,13 @@
           <a:lstStyle/>
           <a:p>
             <a:r>
-              <a:rPr sz="1100" b="0">
+              <a:rPr sz="1050" b="0">
                 <a:solidFill>
                   <a:srgbClr val="1F2937"/>
                 </a:solidFill>
                 <a:latin typeface="Calibri"/>
               </a:rPr>
-              <a:t>Registration and management of sensors</a:t>
+              <a:t>Sensor registry with search / filters, patient assignment, sensitivity, logs and CSV export</a:t>
             </a:r>
           </a:p>
         </p:txBody>
@@ -3971,7 +3976,7 @@
         </p:nvSpPr>
         <p:spPr>
           <a:xfrm>
-            <a:off x="7863840" y="4133088"/>
+            <a:off x="7863840" y="4123944"/>
             <a:ext cx="3840480" cy="274320"/>
           </a:xfrm>
           <a:prstGeom prst="rect">
@@ -4005,8 +4010,8 @@
         </p:nvSpPr>
         <p:spPr>
           <a:xfrm>
-            <a:off x="7863840" y="4407408"/>
-            <a:ext cx="3840480" cy="365760"/>
+            <a:off x="7863840" y="4379976"/>
+            <a:ext cx="3840480" cy="411480"/>
           </a:xfrm>
           <a:prstGeom prst="rect">
             <a:avLst/>
@@ -4020,7 +4025,7 @@
           <a:lstStyle/>
           <a:p>
             <a:r>
-              <a:rPr sz="1100" b="0">
+              <a:rPr sz="1050" b="0">
                 <a:solidFill>
                   <a:srgbClr val="1F2937"/>
                 </a:solidFill>
@@ -4127,7 +4132,7 @@
         </p:nvSpPr>
         <p:spPr>
           <a:xfrm>
-            <a:off x="7863840" y="4937760"/>
+            <a:off x="7863840" y="4928616"/>
             <a:ext cx="3840480" cy="274320"/>
           </a:xfrm>
           <a:prstGeom prst="rect">
@@ -4161,8 +4166,8 @@
         </p:nvSpPr>
         <p:spPr>
           <a:xfrm>
-            <a:off x="7863840" y="5212080"/>
-            <a:ext cx="3840480" cy="365760"/>
+            <a:off x="7863840" y="5184648"/>
+            <a:ext cx="3840480" cy="411480"/>
           </a:xfrm>
           <a:prstGeom prst="rect">
             <a:avLst/>
@@ -4176,7 +4181,7 @@
           <a:lstStyle/>
           <a:p>
             <a:r>
-              <a:rPr sz="1100" b="0">
+              <a:rPr sz="1050" b="0">
                 <a:solidFill>
                   <a:srgbClr val="1F2937"/>
                 </a:solidFill>
@@ -4473,7 +4478,7 @@
         <p:spPr>
           <a:xfrm>
             <a:off x="457200" y="1371600"/>
-            <a:ext cx="5486400" cy="1508760"/>
+            <a:ext cx="3337560" cy="1463040"/>
           </a:xfrm>
           <a:prstGeom prst="rect">
             <a:avLst/>
@@ -4517,7 +4522,7 @@
         <p:spPr>
           <a:xfrm>
             <a:off x="457200" y="1371600"/>
-            <a:ext cx="64008" cy="1508760"/>
+            <a:ext cx="64008" cy="1463040"/>
           </a:xfrm>
           <a:prstGeom prst="rect">
             <a:avLst/>
@@ -4560,8 +4565,8 @@
         </p:nvSpPr>
         <p:spPr>
           <a:xfrm>
-            <a:off x="640080" y="1444752"/>
-            <a:ext cx="5212080" cy="320040"/>
+            <a:off x="640080" y="1426464"/>
+            <a:ext cx="3063240" cy="274320"/>
           </a:xfrm>
           <a:prstGeom prst="rect">
             <a:avLst/>
@@ -4575,7 +4580,7 @@
           <a:lstStyle/>
           <a:p>
             <a:r>
-              <a:rPr sz="1400" b="1">
+              <a:rPr sz="1300" b="1">
                 <a:solidFill>
                   <a:srgbClr val="0B2A4A"/>
                 </a:solidFill>
@@ -4594,8 +4599,8 @@
         </p:nvSpPr>
         <p:spPr>
           <a:xfrm>
-            <a:off x="640080" y="1783080"/>
-            <a:ext cx="5212080" cy="1051560"/>
+            <a:off x="640080" y="1719072"/>
+            <a:ext cx="3063240" cy="1097280"/>
           </a:xfrm>
           <a:prstGeom prst="rect">
             <a:avLst/>
@@ -4609,13 +4614,13 @@
           <a:lstStyle/>
           <a:p>
             <a:r>
-              <a:rPr sz="1200" b="0">
+              <a:rPr sz="1150" b="0">
                 <a:solidFill>
                   <a:srgbClr val="1F2937"/>
                 </a:solidFill>
                 <a:latin typeface="Calibri"/>
               </a:rPr>
-              <a:t>Ward / Room List → Ward → Room navigation with breadcrumb and Back button; patient count shown per room.</a:t>
+              <a:t>Ward / Room List → Ward → Room navigation with breadcrumb and Back button; patient count per room.</a:t>
             </a:r>
           </a:p>
         </p:txBody>
@@ -4628,8 +4633,8 @@
         </p:nvSpPr>
         <p:spPr>
           <a:xfrm>
-            <a:off x="6172200" y="1371600"/>
-            <a:ext cx="5486400" cy="1508760"/>
+            <a:off x="3977639" y="1371600"/>
+            <a:ext cx="3337560" cy="1463040"/>
           </a:xfrm>
           <a:prstGeom prst="rect">
             <a:avLst/>
@@ -4672,8 +4677,8 @@
         </p:nvSpPr>
         <p:spPr>
           <a:xfrm>
-            <a:off x="6172200" y="1371600"/>
-            <a:ext cx="64008" cy="1508760"/>
+            <a:off x="3977639" y="1371600"/>
+            <a:ext cx="64008" cy="1463040"/>
           </a:xfrm>
           <a:prstGeom prst="rect">
             <a:avLst/>
@@ -4716,8 +4721,8 @@
         </p:nvSpPr>
         <p:spPr>
           <a:xfrm>
-            <a:off x="6355080" y="1444752"/>
-            <a:ext cx="5212080" cy="320040"/>
+            <a:off x="4160520" y="1426464"/>
+            <a:ext cx="3063240" cy="274320"/>
           </a:xfrm>
           <a:prstGeom prst="rect">
             <a:avLst/>
@@ -4731,7 +4736,7 @@
           <a:lstStyle/>
           <a:p>
             <a:r>
-              <a:rPr sz="1400" b="1">
+              <a:rPr sz="1300" b="1">
                 <a:solidFill>
                   <a:srgbClr val="0B2A4A"/>
                 </a:solidFill>
@@ -4750,8 +4755,8 @@
         </p:nvSpPr>
         <p:spPr>
           <a:xfrm>
-            <a:off x="6355080" y="1783080"/>
-            <a:ext cx="5212080" cy="1051560"/>
+            <a:off x="4160520" y="1719072"/>
+            <a:ext cx="3063240" cy="1097280"/>
           </a:xfrm>
           <a:prstGeom prst="rect">
             <a:avLst/>
@@ -4765,13 +4770,13 @@
           <a:lstStyle/>
           <a:p>
             <a:r>
-              <a:rPr sz="1200" b="0">
+              <a:rPr sz="1150" b="0">
                 <a:solidFill>
                   <a:srgbClr val="1F2937"/>
                 </a:solidFill>
                 <a:latin typeface="Calibri"/>
               </a:rPr>
-              <a:t>At-a-glance counters per room: Dirty, Connected, Disconnected and Unconnected sensors.</a:t>
+              <a:t>Per-room counters: Dirty, Connected, Disconnected and Unconnected sensors.</a:t>
             </a:r>
           </a:p>
         </p:txBody>
@@ -4784,8 +4789,8 @@
         </p:nvSpPr>
         <p:spPr>
           <a:xfrm>
-            <a:off x="457200" y="3063240"/>
-            <a:ext cx="5486400" cy="1508760"/>
+            <a:off x="457200" y="3017520"/>
+            <a:ext cx="3337560" cy="1463040"/>
           </a:xfrm>
           <a:prstGeom prst="rect">
             <a:avLst/>
@@ -4828,8 +4833,8 @@
         </p:nvSpPr>
         <p:spPr>
           <a:xfrm>
-            <a:off x="457200" y="3063240"/>
-            <a:ext cx="64008" cy="1508760"/>
+            <a:off x="457200" y="3017520"/>
+            <a:ext cx="64008" cy="1463040"/>
           </a:xfrm>
           <a:prstGeom prst="rect">
             <a:avLst/>
@@ -4872,8 +4877,8 @@
         </p:nvSpPr>
         <p:spPr>
           <a:xfrm>
-            <a:off x="640080" y="3136392"/>
-            <a:ext cx="5212080" cy="320040"/>
+            <a:off x="640080" y="3072384"/>
+            <a:ext cx="3063240" cy="274320"/>
           </a:xfrm>
           <a:prstGeom prst="rect">
             <a:avLst/>
@@ -4887,7 +4892,7 @@
           <a:lstStyle/>
           <a:p>
             <a:r>
-              <a:rPr sz="1400" b="1">
+              <a:rPr sz="1300" b="1">
                 <a:solidFill>
                   <a:srgbClr val="0B2A4A"/>
                 </a:solidFill>
@@ -4906,8 +4911,8 @@
         </p:nvSpPr>
         <p:spPr>
           <a:xfrm>
-            <a:off x="640080" y="3474720"/>
-            <a:ext cx="5212080" cy="1051560"/>
+            <a:off x="640080" y="3364991"/>
+            <a:ext cx="3063240" cy="1097280"/>
           </a:xfrm>
           <a:prstGeom prst="rect">
             <a:avLst/>
@@ -4921,13 +4926,13 @@
           <a:lstStyle/>
           <a:p>
             <a:r>
-              <a:rPr sz="1200" b="0">
+              <a:rPr sz="1150" b="0">
                 <a:solidFill>
                   <a:srgbClr val="1F2937"/>
                 </a:solidFill>
                 <a:latin typeface="Calibri"/>
               </a:rPr>
-              <a:t>Each card shows room tag, sensor name, battery level (%), alert toggle, health/status indicator, status bar and last-updated time.</a:t>
+              <a:t>Room tag, sensor name, battery level (%), alert toggle, status indicator and bar, last-updated time.</a:t>
             </a:r>
           </a:p>
         </p:txBody>
@@ -4940,8 +4945,8 @@
         </p:nvSpPr>
         <p:spPr>
           <a:xfrm>
-            <a:off x="6172200" y="3063240"/>
-            <a:ext cx="5486400" cy="1508760"/>
+            <a:off x="3977639" y="3017520"/>
+            <a:ext cx="3337560" cy="1463040"/>
           </a:xfrm>
           <a:prstGeom prst="rect">
             <a:avLst/>
@@ -4984,8 +4989,8 @@
         </p:nvSpPr>
         <p:spPr>
           <a:xfrm>
-            <a:off x="6172200" y="3063240"/>
-            <a:ext cx="64008" cy="1508760"/>
+            <a:off x="3977639" y="3017520"/>
+            <a:ext cx="64008" cy="1463040"/>
           </a:xfrm>
           <a:prstGeom prst="rect">
             <a:avLst/>
@@ -5028,8 +5033,8 @@
         </p:nvSpPr>
         <p:spPr>
           <a:xfrm>
-            <a:off x="6355080" y="3136392"/>
-            <a:ext cx="5212080" cy="320040"/>
+            <a:off x="4160520" y="3072384"/>
+            <a:ext cx="3063240" cy="274320"/>
           </a:xfrm>
           <a:prstGeom prst="rect">
             <a:avLst/>
@@ -5043,13 +5048,13 @@
           <a:lstStyle/>
           <a:p>
             <a:r>
-              <a:rPr sz="1400" b="1">
+              <a:rPr sz="1300" b="1">
                 <a:solidFill>
                   <a:srgbClr val="0B2A4A"/>
                 </a:solidFill>
                 <a:latin typeface="Calibri"/>
               </a:rPr>
-              <a:t>Automatic refresh</a:t>
+              <a:t>Notifications</a:t>
             </a:r>
           </a:p>
         </p:txBody>
@@ -5062,8 +5067,8 @@
         </p:nvSpPr>
         <p:spPr>
           <a:xfrm>
-            <a:off x="6355080" y="3474720"/>
-            <a:ext cx="5212080" cy="1051560"/>
+            <a:off x="4160520" y="3364991"/>
+            <a:ext cx="3063240" cy="1097280"/>
           </a:xfrm>
           <a:prstGeom prst="rect">
             <a:avLst/>
@@ -5077,13 +5082,13 @@
           <a:lstStyle/>
           <a:p>
             <a:r>
-              <a:rPr sz="1200" b="0">
+              <a:rPr sz="1150" b="0">
                 <a:solidFill>
                   <a:srgbClr val="1F2937"/>
                 </a:solidFill>
                 <a:latin typeface="Calibri"/>
               </a:rPr>
-              <a:t>Sensor data updates in near real time; page shows the last-updated time and supports manual refresh.</a:t>
+              <a:t>Per-sensor alert on/off, Room alerts shortcut and Notification History for each sensor.</a:t>
             </a:r>
           </a:p>
         </p:txBody>
@@ -5096,8 +5101,8 @@
         </p:nvSpPr>
         <p:spPr>
           <a:xfrm>
-            <a:off x="457200" y="4754880"/>
-            <a:ext cx="5486400" cy="1508760"/>
+            <a:off x="457200" y="4663440"/>
+            <a:ext cx="3337560" cy="1463040"/>
           </a:xfrm>
           <a:prstGeom prst="rect">
             <a:avLst/>
@@ -5140,8 +5145,8 @@
         </p:nvSpPr>
         <p:spPr>
           <a:xfrm>
-            <a:off x="457200" y="4754880"/>
-            <a:ext cx="64008" cy="1508760"/>
+            <a:off x="457200" y="4663440"/>
+            <a:ext cx="64008" cy="1463040"/>
           </a:xfrm>
           <a:prstGeom prst="rect">
             <a:avLst/>
@@ -5184,8 +5189,8 @@
         </p:nvSpPr>
         <p:spPr>
           <a:xfrm>
-            <a:off x="640080" y="4828032"/>
-            <a:ext cx="5212080" cy="320040"/>
+            <a:off x="640080" y="4718303"/>
+            <a:ext cx="3063240" cy="274320"/>
           </a:xfrm>
           <a:prstGeom prst="rect">
             <a:avLst/>
@@ -5199,13 +5204,13 @@
           <a:lstStyle/>
           <a:p>
             <a:r>
-              <a:rPr sz="1400" b="1">
+              <a:rPr sz="1300" b="1">
                 <a:solidFill>
                   <a:srgbClr val="0B2A4A"/>
                 </a:solidFill>
                 <a:latin typeface="Calibri"/>
               </a:rPr>
-              <a:t>Alerts &amp; notifications</a:t>
+              <a:t>Sensor action menu</a:t>
             </a:r>
           </a:p>
         </p:txBody>
@@ -5218,8 +5223,8 @@
         </p:nvSpPr>
         <p:spPr>
           <a:xfrm>
-            <a:off x="640080" y="5166360"/>
-            <a:ext cx="5212080" cy="1051560"/>
+            <a:off x="640080" y="5010912"/>
+            <a:ext cx="3063240" cy="1097280"/>
           </a:xfrm>
           <a:prstGeom prst="rect">
             <a:avLst/>
@@ -5233,13 +5238,13 @@
           <a:lstStyle/>
           <a:p>
             <a:r>
-              <a:rPr sz="1200" b="0">
+              <a:rPr sz="1150" b="0">
                 <a:solidFill>
                   <a:srgbClr val="1F2937"/>
                 </a:solidFill>
                 <a:latin typeface="Calibri"/>
               </a:rPr>
-              <a:t>Per-sensor alert on/off, Room alerts shortcut, and a Notification History view for each sensor.</a:t>
+              <a:t>Sensitivity · Move room · Edit device info · View sensor info · Delete patient · Unassign sensor from patient.</a:t>
             </a:r>
           </a:p>
         </p:txBody>
@@ -5252,8 +5257,8 @@
         </p:nvSpPr>
         <p:spPr>
           <a:xfrm>
-            <a:off x="6172200" y="4754880"/>
-            <a:ext cx="5486400" cy="1508760"/>
+            <a:off x="3977639" y="4663440"/>
+            <a:ext cx="3337560" cy="1463040"/>
           </a:xfrm>
           <a:prstGeom prst="rect">
             <a:avLst/>
@@ -5296,8 +5301,8 @@
         </p:nvSpPr>
         <p:spPr>
           <a:xfrm>
-            <a:off x="6172200" y="4754880"/>
-            <a:ext cx="64008" cy="1508760"/>
+            <a:off x="3977639" y="4663440"/>
+            <a:ext cx="64008" cy="1463040"/>
           </a:xfrm>
           <a:prstGeom prst="rect">
             <a:avLst/>
@@ -5340,8 +5345,8 @@
         </p:nvSpPr>
         <p:spPr>
           <a:xfrm>
-            <a:off x="6355080" y="4828032"/>
-            <a:ext cx="5212080" cy="320040"/>
+            <a:off x="4160520" y="4718303"/>
+            <a:ext cx="3063240" cy="274320"/>
           </a:xfrm>
           <a:prstGeom prst="rect">
             <a:avLst/>
@@ -5355,13 +5360,13 @@
           <a:lstStyle/>
           <a:p>
             <a:r>
-              <a:rPr sz="1400" b="1">
+              <a:rPr sz="1300" b="1">
                 <a:solidFill>
                   <a:srgbClr val="0B2A4A"/>
                 </a:solidFill>
                 <a:latin typeface="Calibri"/>
               </a:rPr>
-              <a:t>Battery &amp; connectivity awareness</a:t>
+              <a:t>Patient workflow</a:t>
             </a:r>
           </a:p>
         </p:txBody>
@@ -5374,8 +5379,8 @@
         </p:nvSpPr>
         <p:spPr>
           <a:xfrm>
-            <a:off x="6355080" y="5166360"/>
-            <a:ext cx="5212080" cy="1051560"/>
+            <a:off x="4160520" y="5010912"/>
+            <a:ext cx="3063240" cy="1097280"/>
           </a:xfrm>
           <a:prstGeom prst="rect">
             <a:avLst/>
@@ -5389,13 +5394,76 @@
           <a:lstStyle/>
           <a:p>
             <a:r>
-              <a:rPr sz="1200" b="0">
+              <a:rPr sz="1150" b="0">
                 <a:solidFill>
                   <a:srgbClr val="1F2937"/>
                 </a:solidFill>
                 <a:latin typeface="Calibri"/>
               </a:rPr>
-              <a:t>Battery % per sensor and connection state counters help staff spot devices needing attention.</a:t>
+              <a:t>Register info and Assign patient from the Room view; data refreshes automatically with manual refresh option.</a:t>
+            </a:r>
+          </a:p>
+        </p:txBody>
+      </p:sp>
+      <p:pic>
+        <p:nvPicPr>
+          <p:cNvPr id="32" name="Picture 31" descr="sens.png"/>
+          <p:cNvPicPr>
+            <a:picLocks noChangeAspect="1"/>
+          </p:cNvPicPr>
+          <p:nvPr/>
+        </p:nvPicPr>
+        <p:blipFill>
+          <a:blip r:embed="rId2"/>
+          <a:stretch>
+            <a:fillRect/>
+          </a:stretch>
+        </p:blipFill>
+        <p:spPr>
+          <a:xfrm>
+            <a:off x="7589520" y="1325880"/>
+            <a:ext cx="4011912" cy="4480560"/>
+          </a:xfrm>
+          <a:prstGeom prst="rect">
+            <a:avLst/>
+          </a:prstGeom>
+          <a:ln w="9525">
+            <a:solidFill>
+              <a:srgbClr val="D5DCE6"/>
+            </a:solidFill>
+          </a:ln>
+        </p:spPr>
+      </p:pic>
+      <p:sp>
+        <p:nvSpPr>
+          <p:cNvPr id="33" name="TextBox 32"/>
+          <p:cNvSpPr txBox="1"/>
+          <p:nvPr/>
+        </p:nvSpPr>
+        <p:spPr>
+          <a:xfrm>
+            <a:off x="7589520" y="5852160"/>
+            <a:ext cx="4206240" cy="548640"/>
+          </a:xfrm>
+          <a:prstGeom prst="rect">
+            <a:avLst/>
+          </a:prstGeom>
+          <a:noFill/>
+        </p:spPr>
+        <p:txBody>
+          <a:bodyPr wrap="square">
+            <a:spAutoFit/>
+          </a:bodyPr>
+          <a:lstStyle/>
+          <a:p>
+            <a:r>
+              <a:rPr sz="1000" b="0">
+                <a:solidFill>
+                  <a:srgbClr val="6B7A8F"/>
+                </a:solidFill>
+                <a:latin typeface="Calibri"/>
+              </a:rPr>
+              <a:t>Sensitivity Settings: 5 quick presets (Sensitive → Insensitive) or personal level 1–15, set per sensor to suit the user and diaper.</a:t>
             </a:r>
           </a:p>
         </p:txBody>
@@ -5569,7 +5637,7 @@
                 </a:solidFill>
                 <a:latin typeface="Calibri"/>
               </a:rPr>
-              <a:t>Configuration tools for administrators and nursing staff</a:t>
+              <a:t>Sensor registry and facility layout tools for administrators</a:t>
             </a:r>
           </a:p>
         </p:txBody>
@@ -5643,16 +5711,142 @@
           </a:p>
         </p:txBody>
       </p:sp>
-      <p:sp>
-        <p:nvSpPr>
-          <p:cNvPr id="8" name="Rectangle 7"/>
+      <p:pic>
+        <p:nvPicPr>
+          <p:cNvPr id="8" name="Picture 7" descr="manage.png"/>
+          <p:cNvPicPr>
+            <a:picLocks noChangeAspect="1"/>
+          </p:cNvPicPr>
+          <p:nvPr/>
+        </p:nvPicPr>
+        <p:blipFill>
+          <a:blip r:embed="rId2"/>
+          <a:stretch>
+            <a:fillRect/>
+          </a:stretch>
+        </p:blipFill>
+        <p:spPr>
+          <a:xfrm>
+            <a:off x="457200" y="1280160"/>
+            <a:ext cx="5943600" cy="2893337"/>
+          </a:xfrm>
+          <a:prstGeom prst="rect">
+            <a:avLst/>
+          </a:prstGeom>
+          <a:ln w="9525">
+            <a:solidFill>
+              <a:srgbClr val="D5DCE6"/>
+            </a:solidFill>
+          </a:ln>
+        </p:spPr>
+      </p:pic>
+      <p:sp>
+        <p:nvSpPr>
+          <p:cNvPr id="9" name="TextBox 8"/>
+          <p:cNvSpPr txBox="1"/>
+          <p:nvPr/>
+        </p:nvSpPr>
+        <p:spPr>
+          <a:xfrm>
+            <a:off x="457200" y="4114800"/>
+            <a:ext cx="5943600" cy="274320"/>
+          </a:xfrm>
+          <a:prstGeom prst="rect">
+            <a:avLst/>
+          </a:prstGeom>
+          <a:noFill/>
+        </p:spPr>
+        <p:txBody>
+          <a:bodyPr wrap="square">
+            <a:spAutoFit/>
+          </a:bodyPr>
+          <a:lstStyle/>
+          <a:p>
+            <a:r>
+              <a:rPr sz="1000" b="0">
+                <a:solidFill>
+                  <a:srgbClr val="6B7A8F"/>
+                </a:solidFill>
+                <a:latin typeface="Calibri"/>
+              </a:rPr>
+              <a:t>Manage sensors: searchable registry with action menu</a:t>
+            </a:r>
+          </a:p>
+        </p:txBody>
+      </p:sp>
+      <p:pic>
+        <p:nvPicPr>
+          <p:cNvPr id="10" name="Picture 9" descr="layout.png"/>
+          <p:cNvPicPr>
+            <a:picLocks noChangeAspect="1"/>
+          </p:cNvPicPr>
+          <p:nvPr/>
+        </p:nvPicPr>
+        <p:blipFill>
+          <a:blip r:embed="rId3"/>
+          <a:stretch>
+            <a:fillRect/>
+          </a:stretch>
+        </p:blipFill>
+        <p:spPr>
+          <a:xfrm>
+            <a:off x="457200" y="4434840"/>
+            <a:ext cx="5943600" cy="1601133"/>
+          </a:xfrm>
+          <a:prstGeom prst="rect">
+            <a:avLst/>
+          </a:prstGeom>
+          <a:ln w="9525">
+            <a:solidFill>
+              <a:srgbClr val="D5DCE6"/>
+            </a:solidFill>
+          </a:ln>
+        </p:spPr>
+      </p:pic>
+      <p:sp>
+        <p:nvSpPr>
+          <p:cNvPr id="11" name="TextBox 10"/>
+          <p:cNvSpPr txBox="1"/>
+          <p:nvPr/>
+        </p:nvSpPr>
+        <p:spPr>
+          <a:xfrm>
+            <a:off x="457200" y="6126480"/>
+            <a:ext cx="5943600" cy="274320"/>
+          </a:xfrm>
+          <a:prstGeom prst="rect">
+            <a:avLst/>
+          </a:prstGeom>
+          <a:noFill/>
+        </p:spPr>
+        <p:txBody>
+          <a:bodyPr wrap="square">
+            <a:spAutoFit/>
+          </a:bodyPr>
+          <a:lstStyle/>
+          <a:p>
+            <a:r>
+              <a:rPr sz="1000" b="0">
+                <a:solidFill>
+                  <a:srgbClr val="6B7A8F"/>
+                </a:solidFill>
+                <a:latin typeface="Calibri"/>
+              </a:rPr>
+              <a:t>Manage layout: add / edit / remove wards and rooms</a:t>
+            </a:r>
+          </a:p>
+        </p:txBody>
+      </p:sp>
+      <p:sp>
+        <p:nvSpPr>
+          <p:cNvPr id="12" name="Rectangle 11"/>
           <p:cNvSpPr/>
           <p:nvPr/>
         </p:nvSpPr>
         <p:spPr>
           <a:xfrm>
-            <a:off x="457200" y="1371600"/>
-            <a:ext cx="5486400" cy="1280160"/>
+            <a:off x="6675120" y="1280160"/>
+            <a:ext cx="5029200" cy="868680"/>
           </a:xfrm>
           <a:prstGeom prst="rect">
             <a:avLst/>
@@ -5689,14 +5883,14 @@
       </p:sp>
       <p:sp>
         <p:nvSpPr>
-          <p:cNvPr id="9" name="Rectangle 8"/>
+          <p:cNvPr id="13" name="Rectangle 12"/>
           <p:cNvSpPr/>
           <p:nvPr/>
         </p:nvSpPr>
         <p:spPr>
           <a:xfrm>
-            <a:off x="457200" y="1371600"/>
-            <a:ext cx="64008" cy="1280160"/>
+            <a:off x="6675120" y="1280160"/>
+            <a:ext cx="64008" cy="868680"/>
           </a:xfrm>
           <a:prstGeom prst="rect">
             <a:avLst/>
@@ -5733,14 +5927,14 @@
       </p:sp>
       <p:sp>
         <p:nvSpPr>
-          <p:cNvPr id="10" name="TextBox 9"/>
+          <p:cNvPr id="14" name="TextBox 13"/>
           <p:cNvSpPr txBox="1"/>
           <p:nvPr/>
         </p:nvSpPr>
         <p:spPr>
           <a:xfrm>
-            <a:off x="640080" y="1444752"/>
-            <a:ext cx="5212080" cy="320040"/>
+            <a:off x="6858000" y="1335024"/>
+            <a:ext cx="4754880" cy="274320"/>
           </a:xfrm>
           <a:prstGeom prst="rect">
             <a:avLst/>
@@ -5754,27 +5948,27 @@
           <a:lstStyle/>
           <a:p>
             <a:r>
-              <a:rPr sz="1400" b="1">
+              <a:rPr sz="1300" b="1">
                 <a:solidFill>
                   <a:srgbClr val="0B2A4A"/>
                 </a:solidFill>
                 <a:latin typeface="Calibri"/>
               </a:rPr>
-              <a:t>Patient assignment</a:t>
-            </a:r>
-          </a:p>
-        </p:txBody>
-      </p:sp>
-      <p:sp>
-        <p:nvSpPr>
-          <p:cNvPr id="11" name="TextBox 10"/>
+              <a:t>Sensor registry</a:t>
+            </a:r>
+          </a:p>
+        </p:txBody>
+      </p:sp>
+      <p:sp>
+        <p:nvSpPr>
+          <p:cNvPr id="15" name="TextBox 14"/>
           <p:cNvSpPr txBox="1"/>
           <p:nvPr/>
         </p:nvSpPr>
         <p:spPr>
           <a:xfrm>
-            <a:off x="640080" y="1783080"/>
-            <a:ext cx="5212080" cy="822959"/>
+            <a:off x="6858000" y="1627631"/>
+            <a:ext cx="4754880" cy="502919"/>
           </a:xfrm>
           <a:prstGeom prst="rect">
             <a:avLst/>
@@ -5788,27 +5982,27 @@
           <a:lstStyle/>
           <a:p>
             <a:r>
-              <a:rPr sz="1200" b="0">
+              <a:rPr sz="1050" b="0">
                 <a:solidFill>
                   <a:srgbClr val="1F2937"/>
                 </a:solidFill>
                 <a:latin typeface="Calibri"/>
               </a:rPr>
-              <a:t>Assign patient to a sensor from the Room view; Register info to enter patient / sensor details.</a:t>
-            </a:r>
-          </a:p>
-        </p:txBody>
-      </p:sp>
-      <p:sp>
-        <p:nvSpPr>
-          <p:cNvPr id="12" name="Rectangle 11"/>
+              <a:t>Table of Sensor ID, memo, status, device nickname, location, battery and last seen; Register Sensor and Export CSV.</a:t>
+            </a:r>
+          </a:p>
+        </p:txBody>
+      </p:sp>
+      <p:sp>
+        <p:nvSpPr>
+          <p:cNvPr id="16" name="Rectangle 15"/>
           <p:cNvSpPr/>
           <p:nvPr/>
         </p:nvSpPr>
         <p:spPr>
           <a:xfrm>
-            <a:off x="6172200" y="1371600"/>
-            <a:ext cx="5486400" cy="1280160"/>
+            <a:off x="6675120" y="2240280"/>
+            <a:ext cx="5029200" cy="868680"/>
           </a:xfrm>
           <a:prstGeom prst="rect">
             <a:avLst/>
@@ -5845,14 +6039,14 @@
       </p:sp>
       <p:sp>
         <p:nvSpPr>
-          <p:cNvPr id="13" name="Rectangle 12"/>
+          <p:cNvPr id="17" name="Rectangle 16"/>
           <p:cNvSpPr/>
           <p:nvPr/>
         </p:nvSpPr>
         <p:spPr>
           <a:xfrm>
-            <a:off x="6172200" y="1371600"/>
-            <a:ext cx="64008" cy="1280160"/>
+            <a:off x="6675120" y="2240280"/>
+            <a:ext cx="64008" cy="868680"/>
           </a:xfrm>
           <a:prstGeom prst="rect">
             <a:avLst/>
@@ -5889,14 +6083,14 @@
       </p:sp>
       <p:sp>
         <p:nvSpPr>
-          <p:cNvPr id="14" name="TextBox 13"/>
+          <p:cNvPr id="18" name="TextBox 17"/>
           <p:cNvSpPr txBox="1"/>
           <p:nvPr/>
         </p:nvSpPr>
         <p:spPr>
           <a:xfrm>
-            <a:off x="6355080" y="1444752"/>
-            <a:ext cx="5212080" cy="320040"/>
+            <a:off x="6858000" y="2295144"/>
+            <a:ext cx="4754880" cy="274320"/>
           </a:xfrm>
           <a:prstGeom prst="rect">
             <a:avLst/>
@@ -5910,27 +6104,27 @@
           <a:lstStyle/>
           <a:p>
             <a:r>
-              <a:rPr sz="1400" b="1">
+              <a:rPr sz="1300" b="1">
                 <a:solidFill>
                   <a:srgbClr val="0B2A4A"/>
                 </a:solidFill>
                 <a:latin typeface="Calibri"/>
               </a:rPr>
-              <a:t>Manage layout</a:t>
-            </a:r>
-          </a:p>
-        </p:txBody>
-      </p:sp>
-      <p:sp>
-        <p:nvSpPr>
-          <p:cNvPr id="15" name="TextBox 14"/>
+              <a:t>Search &amp; filters</a:t>
+            </a:r>
+          </a:p>
+        </p:txBody>
+      </p:sp>
+      <p:sp>
+        <p:nvSpPr>
+          <p:cNvPr id="19" name="TextBox 18"/>
           <p:cNvSpPr txBox="1"/>
           <p:nvPr/>
         </p:nvSpPr>
         <p:spPr>
           <a:xfrm>
-            <a:off x="6355080" y="1783080"/>
-            <a:ext cx="5212080" cy="822959"/>
+            <a:off x="6858000" y="2587752"/>
+            <a:ext cx="4754880" cy="502919"/>
           </a:xfrm>
           <a:prstGeom prst="rect">
             <a:avLst/>
@@ -5944,27 +6138,27 @@
           <a:lstStyle/>
           <a:p>
             <a:r>
-              <a:rPr sz="1200" b="0">
+              <a:rPr sz="1050" b="0">
                 <a:solidFill>
                   <a:srgbClr val="1F2937"/>
                 </a:solidFill>
                 <a:latin typeface="Calibri"/>
               </a:rPr>
-              <a:t>Administrators can arrange the dashboard layout of wards and rooms to match the facility.</a:t>
-            </a:r>
-          </a:p>
-        </p:txBody>
-      </p:sp>
-      <p:sp>
-        <p:nvSpPr>
-          <p:cNvPr id="16" name="Rectangle 15"/>
+              <a:t>Filter by Ward, Room or Device nickname, plus status and battery level filters.</a:t>
+            </a:r>
+          </a:p>
+        </p:txBody>
+      </p:sp>
+      <p:sp>
+        <p:nvSpPr>
+          <p:cNvPr id="20" name="Rectangle 19"/>
           <p:cNvSpPr/>
           <p:nvPr/>
         </p:nvSpPr>
         <p:spPr>
           <a:xfrm>
-            <a:off x="457200" y="2834640"/>
-            <a:ext cx="5486400" cy="1280160"/>
+            <a:off x="6675120" y="3200400"/>
+            <a:ext cx="5029200" cy="868680"/>
           </a:xfrm>
           <a:prstGeom prst="rect">
             <a:avLst/>
@@ -6001,14 +6195,14 @@
       </p:sp>
       <p:sp>
         <p:nvSpPr>
-          <p:cNvPr id="17" name="Rectangle 16"/>
+          <p:cNvPr id="21" name="Rectangle 20"/>
           <p:cNvSpPr/>
           <p:nvPr/>
         </p:nvSpPr>
         <p:spPr>
           <a:xfrm>
-            <a:off x="457200" y="2834640"/>
-            <a:ext cx="64008" cy="1280160"/>
+            <a:off x="6675120" y="3200400"/>
+            <a:ext cx="64008" cy="868680"/>
           </a:xfrm>
           <a:prstGeom prst="rect">
             <a:avLst/>
@@ -6045,14 +6239,14 @@
       </p:sp>
       <p:sp>
         <p:nvSpPr>
-          <p:cNvPr id="18" name="TextBox 17"/>
+          <p:cNvPr id="22" name="TextBox 21"/>
           <p:cNvSpPr txBox="1"/>
           <p:nvPr/>
         </p:nvSpPr>
         <p:spPr>
           <a:xfrm>
-            <a:off x="640080" y="2907792"/>
-            <a:ext cx="5212080" cy="320040"/>
+            <a:off x="6858000" y="3255264"/>
+            <a:ext cx="4754880" cy="274320"/>
           </a:xfrm>
           <a:prstGeom prst="rect">
             <a:avLst/>
@@ -6066,27 +6260,27 @@
           <a:lstStyle/>
           <a:p>
             <a:r>
-              <a:rPr sz="1400" b="1">
+              <a:rPr sz="1300" b="1">
                 <a:solidFill>
                   <a:srgbClr val="0B2A4A"/>
                 </a:solidFill>
                 <a:latin typeface="Calibri"/>
               </a:rPr>
-              <a:t>Sensor &amp; device management</a:t>
-            </a:r>
-          </a:p>
-        </p:txBody>
-      </p:sp>
-      <p:sp>
-        <p:nvSpPr>
-          <p:cNvPr id="19" name="TextBox 18"/>
+              <a:t>Per-sensor actions</a:t>
+            </a:r>
+          </a:p>
+        </p:txBody>
+      </p:sp>
+      <p:sp>
+        <p:nvSpPr>
+          <p:cNvPr id="23" name="TextBox 22"/>
           <p:cNvSpPr txBox="1"/>
           <p:nvPr/>
         </p:nvSpPr>
         <p:spPr>
           <a:xfrm>
-            <a:off x="640080" y="3246120"/>
-            <a:ext cx="5212080" cy="822959"/>
+            <a:off x="6858000" y="3547872"/>
+            <a:ext cx="4754880" cy="502919"/>
           </a:xfrm>
           <a:prstGeom prst="rect">
             <a:avLst/>
@@ -6100,27 +6294,27 @@
           <a:lstStyle/>
           <a:p>
             <a:r>
-              <a:rPr sz="1200" b="0">
+              <a:rPr sz="1050" b="0">
                 <a:solidFill>
                   <a:srgbClr val="1F2937"/>
                 </a:solidFill>
                 <a:latin typeface="Calibri"/>
               </a:rPr>
-              <a:t>Dedicated Manage sensors and Device info menus for registering and reviewing devices.</a:t>
-            </a:r>
-          </a:p>
-        </p:txBody>
-      </p:sp>
-      <p:sp>
-        <p:nvSpPr>
-          <p:cNvPr id="20" name="Rectangle 19"/>
+              <a:t>Sensitivity · Assign Patient · Edit info · Logs · Delete.</a:t>
+            </a:r>
+          </a:p>
+        </p:txBody>
+      </p:sp>
+      <p:sp>
+        <p:nvSpPr>
+          <p:cNvPr id="24" name="Rectangle 23"/>
           <p:cNvSpPr/>
           <p:nvPr/>
         </p:nvSpPr>
         <p:spPr>
           <a:xfrm>
-            <a:off x="6172200" y="2834640"/>
-            <a:ext cx="5486400" cy="1280160"/>
+            <a:off x="6675120" y="4160520"/>
+            <a:ext cx="5029200" cy="868680"/>
           </a:xfrm>
           <a:prstGeom prst="rect">
             <a:avLst/>
@@ -6157,14 +6351,14 @@
       </p:sp>
       <p:sp>
         <p:nvSpPr>
-          <p:cNvPr id="21" name="Rectangle 20"/>
+          <p:cNvPr id="25" name="Rectangle 24"/>
           <p:cNvSpPr/>
           <p:nvPr/>
         </p:nvSpPr>
         <p:spPr>
           <a:xfrm>
-            <a:off x="6172200" y="2834640"/>
-            <a:ext cx="64008" cy="1280160"/>
+            <a:off x="6675120" y="4160520"/>
+            <a:ext cx="64008" cy="868680"/>
           </a:xfrm>
           <a:prstGeom prst="rect">
             <a:avLst/>
@@ -6201,14 +6395,14 @@
       </p:sp>
       <p:sp>
         <p:nvSpPr>
-          <p:cNvPr id="22" name="TextBox 21"/>
+          <p:cNvPr id="26" name="TextBox 25"/>
           <p:cNvSpPr txBox="1"/>
           <p:nvPr/>
         </p:nvSpPr>
         <p:spPr>
           <a:xfrm>
-            <a:off x="6355080" y="2907792"/>
-            <a:ext cx="5212080" cy="320040"/>
+            <a:off x="6858000" y="4215384"/>
+            <a:ext cx="4754880" cy="274320"/>
           </a:xfrm>
           <a:prstGeom prst="rect">
             <a:avLst/>
@@ -6222,27 +6416,27 @@
           <a:lstStyle/>
           <a:p>
             <a:r>
-              <a:rPr sz="1400" b="1">
+              <a:rPr sz="1300" b="1">
                 <a:solidFill>
                   <a:srgbClr val="0B2A4A"/>
                 </a:solidFill>
                 <a:latin typeface="Calibri"/>
               </a:rPr>
-              <a:t>Global search</a:t>
-            </a:r>
-          </a:p>
-        </p:txBody>
-      </p:sp>
-      <p:sp>
-        <p:nvSpPr>
-          <p:cNvPr id="23" name="TextBox 22"/>
+              <a:t>Layout management</a:t>
+            </a:r>
+          </a:p>
+        </p:txBody>
+      </p:sp>
+      <p:sp>
+        <p:nvSpPr>
+          <p:cNvPr id="27" name="TextBox 26"/>
           <p:cNvSpPr txBox="1"/>
           <p:nvPr/>
         </p:nvSpPr>
         <p:spPr>
           <a:xfrm>
-            <a:off x="6355080" y="3246120"/>
-            <a:ext cx="5212080" cy="822959"/>
+            <a:off x="6858000" y="4507992"/>
+            <a:ext cx="4754880" cy="502919"/>
           </a:xfrm>
           <a:prstGeom prst="rect">
             <a:avLst/>
@@ -6256,27 +6450,27 @@
           <a:lstStyle/>
           <a:p>
             <a:r>
-              <a:rPr sz="1200" b="0">
+              <a:rPr sz="1050" b="0">
                 <a:solidFill>
                   <a:srgbClr val="1F2937"/>
                 </a:solidFill>
                 <a:latin typeface="Calibri"/>
               </a:rPr>
-              <a:t>Single search box to find a ward, room, patient or sensor quickly.</a:t>
-            </a:r>
-          </a:p>
-        </p:txBody>
-      </p:sp>
-      <p:sp>
-        <p:nvSpPr>
-          <p:cNvPr id="24" name="Rectangle 23"/>
+              <a:t>Add Ward / Add Room, rename, delete; Save All, Discard and Close to control changes.</a:t>
+            </a:r>
+          </a:p>
+        </p:txBody>
+      </p:sp>
+      <p:sp>
+        <p:nvSpPr>
+          <p:cNvPr id="28" name="Rectangle 27"/>
           <p:cNvSpPr/>
           <p:nvPr/>
         </p:nvSpPr>
         <p:spPr>
           <a:xfrm>
-            <a:off x="457200" y="4297680"/>
-            <a:ext cx="5486400" cy="1280160"/>
+            <a:off x="6675120" y="5120640"/>
+            <a:ext cx="5029200" cy="868680"/>
           </a:xfrm>
           <a:prstGeom prst="rect">
             <a:avLst/>
@@ -6313,14 +6507,14 @@
       </p:sp>
       <p:sp>
         <p:nvSpPr>
-          <p:cNvPr id="25" name="Rectangle 24"/>
+          <p:cNvPr id="29" name="Rectangle 28"/>
           <p:cNvSpPr/>
           <p:nvPr/>
         </p:nvSpPr>
         <p:spPr>
           <a:xfrm>
-            <a:off x="457200" y="4297680"/>
-            <a:ext cx="64008" cy="1280160"/>
+            <a:off x="6675120" y="5120640"/>
+            <a:ext cx="64008" cy="868680"/>
           </a:xfrm>
           <a:prstGeom prst="rect">
             <a:avLst/>
@@ -6357,14 +6551,14 @@
       </p:sp>
       <p:sp>
         <p:nvSpPr>
-          <p:cNvPr id="26" name="TextBox 25"/>
+          <p:cNvPr id="30" name="TextBox 29"/>
           <p:cNvSpPr txBox="1"/>
           <p:nvPr/>
         </p:nvSpPr>
         <p:spPr>
           <a:xfrm>
-            <a:off x="640080" y="4370832"/>
-            <a:ext cx="5212080" cy="320040"/>
+            <a:off x="6858000" y="5175503"/>
+            <a:ext cx="4754880" cy="274320"/>
           </a:xfrm>
           <a:prstGeom prst="rect">
             <a:avLst/>
@@ -6378,27 +6572,27 @@
           <a:lstStyle/>
           <a:p>
             <a:r>
-              <a:rPr sz="1400" b="1">
+              <a:rPr sz="1300" b="1">
                 <a:solidFill>
                   <a:srgbClr val="0B2A4A"/>
                 </a:solidFill>
                 <a:latin typeface="Calibri"/>
               </a:rPr>
-              <a:t>Role-based organisation access</a:t>
-            </a:r>
-          </a:p>
-        </p:txBody>
-      </p:sp>
-      <p:sp>
-        <p:nvSpPr>
-          <p:cNvPr id="27" name="TextBox 26"/>
+              <a:t>Access &amp; localisation</a:t>
+            </a:r>
+          </a:p>
+        </p:txBody>
+      </p:sp>
+      <p:sp>
+        <p:nvSpPr>
+          <p:cNvPr id="31" name="TextBox 30"/>
           <p:cNvSpPr txBox="1"/>
           <p:nvPr/>
         </p:nvSpPr>
         <p:spPr>
           <a:xfrm>
-            <a:off x="640080" y="4709160"/>
-            <a:ext cx="5212080" cy="822959"/>
+            <a:off x="6858000" y="5468112"/>
+            <a:ext cx="4754880" cy="502919"/>
           </a:xfrm>
           <a:prstGeom prst="rect">
             <a:avLst/>
@@ -6412,115 +6606,27 @@
           <a:lstStyle/>
           <a:p>
             <a:r>
-              <a:rPr sz="1200" b="0">
+              <a:rPr sz="1050" b="0">
                 <a:solidFill>
                   <a:srgbClr val="1F2937"/>
                 </a:solidFill>
                 <a:latin typeface="Calibri"/>
               </a:rPr>
-              <a:t>Sign-in under an organisation account (e.g., organization_admin) scoped to that organisation’s data.</a:t>
-            </a:r>
-          </a:p>
-        </p:txBody>
-      </p:sp>
-      <p:sp>
-        <p:nvSpPr>
-          <p:cNvPr id="28" name="Rectangle 27"/>
-          <p:cNvSpPr/>
-          <p:nvPr/>
-        </p:nvSpPr>
-        <p:spPr>
-          <a:xfrm>
-            <a:off x="6172200" y="4297680"/>
-            <a:ext cx="5486400" cy="1280160"/>
-          </a:xfrm>
-          <a:prstGeom prst="rect">
-            <a:avLst/>
-          </a:prstGeom>
-          <a:solidFill>
-            <a:srgbClr val="F1F4F8"/>
-          </a:solidFill>
-          <a:ln>
-            <a:noFill/>
-          </a:ln>
-          <a:effectLst/>
-        </p:spPr>
-        <p:style>
-          <a:lnRef idx="1">
-            <a:schemeClr val="accent1"/>
-          </a:lnRef>
-          <a:fillRef idx="3">
-            <a:schemeClr val="accent1"/>
-          </a:fillRef>
-          <a:effectRef idx="2">
-            <a:schemeClr val="accent1"/>
-          </a:effectRef>
-          <a:fontRef idx="minor">
-            <a:schemeClr val="lt1"/>
-          </a:fontRef>
-        </p:style>
-        <p:txBody>
-          <a:bodyPr rtlCol="0" anchor="ctr"/>
-          <a:lstStyle/>
-          <a:p>
-            <a:pPr algn="ctr"/>
-          </a:p>
-        </p:txBody>
-      </p:sp>
-      <p:sp>
-        <p:nvSpPr>
-          <p:cNvPr id="29" name="Rectangle 28"/>
-          <p:cNvSpPr/>
-          <p:nvPr/>
-        </p:nvSpPr>
-        <p:spPr>
-          <a:xfrm>
-            <a:off x="6172200" y="4297680"/>
-            <a:ext cx="64008" cy="1280160"/>
-          </a:xfrm>
-          <a:prstGeom prst="rect">
-            <a:avLst/>
-          </a:prstGeom>
-          <a:solidFill>
-            <a:srgbClr val="00A3AD"/>
-          </a:solidFill>
-          <a:ln>
-            <a:noFill/>
-          </a:ln>
-          <a:effectLst/>
-        </p:spPr>
-        <p:style>
-          <a:lnRef idx="1">
-            <a:schemeClr val="accent1"/>
-          </a:lnRef>
-          <a:fillRef idx="3">
-            <a:schemeClr val="accent1"/>
-          </a:fillRef>
-          <a:effectRef idx="2">
-            <a:schemeClr val="accent1"/>
-          </a:effectRef>
-          <a:fontRef idx="minor">
-            <a:schemeClr val="lt1"/>
-          </a:fontRef>
-        </p:style>
-        <p:txBody>
-          <a:bodyPr rtlCol="0" anchor="ctr"/>
-          <a:lstStyle/>
-          <a:p>
-            <a:pPr algn="ctr"/>
-          </a:p>
-        </p:txBody>
-      </p:sp>
-      <p:sp>
-        <p:nvSpPr>
-          <p:cNvPr id="30" name="TextBox 29"/>
+              <a:t>Organisation-scoped sign-in (e.g., organization_admin), global search and language selector.</a:t>
+            </a:r>
+          </a:p>
+        </p:txBody>
+      </p:sp>
+      <p:sp>
+        <p:nvSpPr>
+          <p:cNvPr id="32" name="TextBox 31"/>
           <p:cNvSpPr txBox="1"/>
           <p:nvPr/>
         </p:nvSpPr>
         <p:spPr>
           <a:xfrm>
-            <a:off x="6355080" y="4370832"/>
-            <a:ext cx="5212080" cy="320040"/>
+            <a:off x="6675120" y="6080760"/>
+            <a:ext cx="5029200" cy="365760"/>
           </a:xfrm>
           <a:prstGeom prst="rect">
             <a:avLst/>
@@ -6534,81 +6640,13 @@
           <a:lstStyle/>
           <a:p>
             <a:r>
-              <a:rPr sz="1400" b="1">
-                <a:solidFill>
-                  <a:srgbClr val="0B2A4A"/>
+              <a:rPr sz="950" b="0">
+                <a:solidFill>
+                  <a:srgbClr val="6B7A8F"/>
                 </a:solidFill>
                 <a:latin typeface="Calibri"/>
               </a:rPr>
-              <a:t>Multi-language UI</a:t>
-            </a:r>
-          </a:p>
-        </p:txBody>
-      </p:sp>
-      <p:sp>
-        <p:nvSpPr>
-          <p:cNvPr id="31" name="TextBox 30"/>
-          <p:cNvSpPr txBox="1"/>
-          <p:nvPr/>
-        </p:nvSpPr>
-        <p:spPr>
-          <a:xfrm>
-            <a:off x="6355080" y="4709160"/>
-            <a:ext cx="5212080" cy="822959"/>
-          </a:xfrm>
-          <a:prstGeom prst="rect">
-            <a:avLst/>
-          </a:prstGeom>
-          <a:noFill/>
-        </p:spPr>
-        <p:txBody>
-          <a:bodyPr wrap="square">
-            <a:spAutoFit/>
-          </a:bodyPr>
-          <a:lstStyle/>
-          <a:p>
-            <a:r>
-              <a:rPr sz="1200" b="0">
-                <a:solidFill>
-                  <a:srgbClr val="1F2937"/>
-                </a:solidFill>
-                <a:latin typeface="Calibri"/>
-              </a:rPr>
-              <a:t>Language selector (English shown) for international deployments.</a:t>
-            </a:r>
-          </a:p>
-        </p:txBody>
-      </p:sp>
-      <p:sp>
-        <p:nvSpPr>
-          <p:cNvPr id="32" name="TextBox 31"/>
-          <p:cNvSpPr txBox="1"/>
-          <p:nvPr/>
-        </p:nvSpPr>
-        <p:spPr>
-          <a:xfrm>
-            <a:off x="457200" y="5852160"/>
-            <a:ext cx="11247120" cy="457200"/>
-          </a:xfrm>
-          <a:prstGeom prst="rect">
-            <a:avLst/>
-          </a:prstGeom>
-          <a:noFill/>
-        </p:spPr>
-        <p:txBody>
-          <a:bodyPr wrap="square">
-            <a:spAutoFit/>
-          </a:bodyPr>
-          <a:lstStyle/>
-          <a:p>
-            <a:r>
-              <a:rPr sz="1000" b="0">
-                <a:solidFill>
-                  <a:srgbClr val="6B7A8F"/>
-                </a:solidFill>
-                <a:latin typeface="Calibri"/>
-              </a:rPr>
-              <a:t>Note: Features are described from the dashboard screen shown above; Device info, Manage sensors, Alerts and Settings menus are listed by name. Functions may evolve with product versions.</a:t>
+              <a:t>Device info, Alerts and Settings menus are listed by name only. Features may evolve with product versions.</a:t>
             </a:r>
           </a:p>
         </p:txBody>

</xml_diff>